<commit_message>
PPTX Do y does: apóstrofo recto en el título de negativos y quitar '8 min' de la portada
Co-Authored-By: Claude Sonnet 5.5 <noreply@anthropic.com>
Claude-Session: https://claude.ai/code/session_01AK9pnJM83quWWTt8tkL4QY
</commit_message>
<xml_diff>
--- a/microclase-do-does.pptx
+++ b/microclase-do-does.pptx
@@ -2750,7 +2750,7 @@
         <p:spPr>
           <a:xfrm>
             <a:off x="548640" y="1188720"/>
-            <a:ext cx="2377440" cy="457200"/>
+            <a:ext cx="1463040" cy="457200"/>
           </a:xfrm>
           <a:prstGeom prst="roundRect">
             <a:avLst>
@@ -2777,7 +2777,7 @@
         <p:spPr>
           <a:xfrm>
             <a:off x="548640" y="1188720"/>
-            <a:ext cx="2377440" cy="457200"/>
+            <a:ext cx="1463040" cy="457200"/>
           </a:xfrm>
           <a:prstGeom prst="rect">
             <a:avLst/>
@@ -2801,7 +2801,7 @@
                 <a:ea typeface="Work Sans" pitchFamily="34" charset="-122"/>
                 <a:cs typeface="Work Sans" pitchFamily="34" charset="-120"/>
               </a:rPr>
-              <a:t>Microclase · 8 min</a:t>
+              <a:t>Microclase</a:t>
             </a:r>
             <a:endParaRPr lang="en-US" sz="1600" dirty="0"/>
           </a:p>
@@ -7093,7 +7093,7 @@
                 <a:ea typeface="Big Shoulders Display" pitchFamily="34" charset="-122"/>
                 <a:cs typeface="Big Shoulders Display" pitchFamily="34" charset="-120"/>
               </a:rPr>
-              <a:t>NEGATIVOS: DON’T Y DOESN’T</a:t>
+              <a:t>NEGATIVOS: DON'T Y DOESN'T</a:t>
             </a:r>
             <a:endParaRPr lang="en-US" sz="3600" dirty="0"/>
           </a:p>

</xml_diff>